<commit_message>
Rename firm to Malpani Group across app, docs, deck, pdf and screenshots
</commit_message>
<xml_diff>
--- a/Project_Overview.pptx
+++ b/Project_Overview.pptx
@@ -3259,7 +3259,7 @@
                 </a:solidFill>
                 <a:latin typeface="Calibri"/>
               </a:rPr>
-              <a:t>PackRight Manufacturing · Corrugated Cartons &amp; Packaging Materials · Capstone (Topic 04)</a:t>
+              <a:t>Malpani Group · Corrugated Cartons &amp; Packaging Materials · Capstone (Topic 04)</a:t>
             </a:r>
           </a:p>
         </p:txBody>
@@ -4870,7 +4870,7 @@
                 </a:solidFill>
                 <a:latin typeface="Calibri"/>
               </a:rPr>
-              <a:t>· Browser-based app (Streamlit-style UI, static)</a:t>
+              <a:t>· Browser-based app (static)</a:t>
             </a:r>
           </a:p>
         </p:txBody>
@@ -5027,7 +5027,7 @@
                   <a:srgbClr val="555F6E"/>
                 </a:solidFill>
               </a:rPr>
-              <a:t>purchase, no payment and no contractual commitment on its own — the final financial decision always rests with authorised PackRight personnel.</a:t>
+              <a:t>purchase, no payment and no contractual commitment on its own — the final financial decision always rests with authorised Malpani Group personnel.</a:t>
             </a:r>
           </a:p>
         </p:txBody>
@@ -5066,7 +5066,7 @@
                 </a:solidFill>
                 <a:latin typeface="Calibri"/>
               </a:rPr>
-              <a:t>PackRight Manufacturing · Gen AI for Business capstone — synthetic sample data, no real purchase commitments.</a:t>
+              <a:t>Malpani Group · Gen AI for Business capstone — synthetic sample data, no real purchase commitments.</a:t>
             </a:r>
           </a:p>
         </p:txBody>

</xml_diff>